<commit_message>
New Youssef's Additions and refactoring
</commit_message>
<xml_diff>
--- a/Resources/Templates/ABT/ABT_rev1/ABT_REL_Rev1_08022026.pptx
+++ b/Resources/Templates/ABT/ABT_rev1/ABT_REL_Rev1_08022026.pptx
@@ -239,7 +239,7 @@
           <a:p>
             <a:fld id="{5A2993FE-E9D3-4B10-B499-4235062A8B3B}" type="datetimeFigureOut">
               <a:rPr lang="en-US" smtClean="0"/>
-              <a:t>8/9/2026</a:t>
+              <a:t>8/13/2026</a:t>
             </a:fld>
             <a:endParaRPr lang="en-US"/>
           </a:p>
@@ -417,7 +417,7 @@
           <a:p>
             <a:fld id="{DD2E5E3A-6FB5-47BF-ABCF-397F6C94D529}" type="datetimeFigureOut">
               <a:rPr lang="en-US" smtClean="0"/>
-              <a:t>8/9/2026</a:t>
+              <a:t>8/13/2026</a:t>
             </a:fld>
             <a:endParaRPr lang="en-US" dirty="0"/>
           </a:p>
@@ -26896,9 +26896,9 @@
         <p:grpSpPr>
           <a:xfrm>
             <a:off x="1996469" y="2982119"/>
-            <a:ext cx="4925807" cy="261610"/>
+            <a:ext cx="4925807" cy="430887"/>
             <a:chOff x="4092326" y="1688590"/>
-            <a:chExt cx="4925807" cy="261610"/>
+            <a:chExt cx="4925807" cy="430887"/>
           </a:xfrm>
         </p:grpSpPr>
         <p:sp>
@@ -26916,7 +26916,7 @@
           <p:spPr>
             <a:xfrm>
               <a:off x="5198127" y="1688590"/>
-              <a:ext cx="3820006" cy="261610"/>
+              <a:ext cx="3820006" cy="430887"/>
             </a:xfrm>
             <a:prstGeom prst="rect">
               <a:avLst/>
@@ -26938,7 +26938,7 @@
                   <a:ea typeface="Tahoma" panose="020B0604030504040204" pitchFamily="34" charset="0"/>
                   <a:cs typeface="Tahoma" panose="020B0604030504040204" pitchFamily="34" charset="0"/>
                 </a:rPr>
-                <a:t>Should be ON !</a:t>
+                <a:t>Should be ON most of the cases , but for C groove should be Off </a:t>
               </a:r>
             </a:p>
           </p:txBody>
@@ -28321,9 +28321,9 @@
         <p:grpSpPr>
           <a:xfrm>
             <a:off x="3516713" y="2137523"/>
-            <a:ext cx="8482627" cy="1277273"/>
+            <a:ext cx="8482627" cy="1446550"/>
             <a:chOff x="4092326" y="1688590"/>
-            <a:chExt cx="6554662" cy="1277273"/>
+            <a:chExt cx="6554662" cy="1446550"/>
           </a:xfrm>
         </p:grpSpPr>
         <p:sp>
@@ -28341,7 +28341,7 @@
           <p:spPr>
             <a:xfrm>
               <a:off x="5198126" y="1688590"/>
-              <a:ext cx="5448862" cy="1277273"/>
+              <a:ext cx="5448862" cy="1446550"/>
             </a:xfrm>
             <a:prstGeom prst="rect">
               <a:avLst/>
@@ -28385,7 +28385,29 @@
                   <a:ea typeface="Tahoma" panose="020B0604030504040204" pitchFamily="34" charset="0"/>
                   <a:cs typeface="Tahoma" panose="020B0604030504040204" pitchFamily="34" charset="0"/>
                 </a:rPr>
-                <a:t> </a:t>
+                <a:t> : </a:t>
+              </a:r>
+              <a:r>
+                <a:rPr lang="en-US" sz="1100" dirty="0" err="1">
+                  <a:solidFill>
+                    <a:srgbClr val="FF0000"/>
+                  </a:solidFill>
+                  <a:latin typeface="Tahoma" panose="020B0604030504040204" pitchFamily="34" charset="0"/>
+                  <a:ea typeface="Tahoma" panose="020B0604030504040204" pitchFamily="34" charset="0"/>
+                  <a:cs typeface="Tahoma" panose="020B0604030504040204" pitchFamily="34" charset="0"/>
+                </a:rPr>
+                <a:t>std_round_br</a:t>
+              </a:r>
+              <a:r>
+                <a:rPr lang="en-US" sz="1100" dirty="0">
+                  <a:solidFill>
+                    <a:srgbClr val="FF0000"/>
+                  </a:solidFill>
+                  <a:latin typeface="Tahoma" panose="020B0604030504040204" pitchFamily="34" charset="0"/>
+                  <a:ea typeface="Tahoma" panose="020B0604030504040204" pitchFamily="34" charset="0"/>
+                  <a:cs typeface="Tahoma" panose="020B0604030504040204" pitchFamily="34" charset="0"/>
+                </a:rPr>
+                <a:t> should be OFF</a:t>
               </a:r>
               <a:br>
                 <a:rPr lang="en-US" sz="1100" dirty="0">
@@ -28733,6 +28755,24 @@
                 </a:rPr>
                 <a:t>Based on FRO and FR values , CBR needs CBRL &amp; CBRD</a:t>
               </a:r>
+              <a:br>
+                <a:rPr lang="en-US" sz="1100" dirty="0">
+                  <a:solidFill>
+                    <a:srgbClr val="FF0000"/>
+                  </a:solidFill>
+                  <a:latin typeface="Tahoma" panose="020B0604030504040204" pitchFamily="34" charset="0"/>
+                  <a:ea typeface="Tahoma" panose="020B0604030504040204" pitchFamily="34" charset="0"/>
+                  <a:cs typeface="Tahoma" panose="020B0604030504040204" pitchFamily="34" charset="0"/>
+                </a:rPr>
+              </a:br>
+              <a:endParaRPr lang="en-US" sz="1100" dirty="0">
+                <a:solidFill>
+                  <a:srgbClr val="FF0000"/>
+                </a:solidFill>
+                <a:latin typeface="Tahoma" panose="020B0604030504040204" pitchFamily="34" charset="0"/>
+                <a:ea typeface="Tahoma" panose="020B0604030504040204" pitchFamily="34" charset="0"/>
+                <a:cs typeface="Tahoma" panose="020B0604030504040204" pitchFamily="34" charset="0"/>
+              </a:endParaRPr>
             </a:p>
           </p:txBody>
         </p:sp>

</xml_diff>